<commit_message>
Q3: close result tables and evidence-level cases
</commit_message>
<xml_diff>
--- a/Q1_论文绘图数据与LaTeX交付包/Q1_论文绘图数据与LaTeX交付包/paper/figures/q3/fig14_q3_heaf_framework_source.pptx
+++ b/Q1_论文绘图数据与LaTeX交付包/Q1_论文绘图数据与LaTeX交付包/paper/figures/q3/fig14_q3_heaf_framework_source.pptx
@@ -10008,7 +10008,7 @@
                 </a:solidFill>
                 <a:latin typeface="Microsoft YaHei"/>
               </a:rPr>
-              <a:t>证据</a:t>
+              <a:t>特征</a:t>
             </a:r>
             <a:endParaRPr sz="1110" b="0" dirty="0">
               <a:solidFill>
@@ -12108,7 +12108,7 @@
                 <a:latin typeface="宋体" panose="02010600030101010101" pitchFamily="2" charset="-122"/>
                 <a:ea typeface="宋体" panose="02010600030101010101" pitchFamily="2" charset="-122"/>
               </a:rPr>
-              <a:t>仅定位特征槽位</a:t>
+              <a:t>未对齐特征行</a:t>
             </a:r>
           </a:p>
         </p:txBody>
@@ -12285,7 +12285,7 @@
                 <a:latin typeface="宋体" panose="02010600030101010101" pitchFamily="2" charset="-122"/>
                 <a:ea typeface="宋体" panose="02010600030101010101" pitchFamily="2" charset="-122"/>
               </a:rPr>
-              <a:t>未核验</a:t>
+              <a:t>已核验</a:t>
             </a:r>
           </a:p>
         </p:txBody>

</xml_diff>